<commit_message>
Add Lambda independent-review stage, architecture card, retitle
- incident_loop: stage 4/5 sends before/after telemetry to a reviewer model
  served on a Lambda GPU (Ollama via SSH tunnel); verdict goes into the issue
- lambda_reviewer.sh: setup / tunnel / status for the instance
- record_incident: opens with the architecture card, adds the review card
- heading is now Robotic Simulation Incident Analysis (README, slide, video)

Co-Authored-By: Claude Fable 5.1 <noreply@anthropic.com>
</commit_message>
<xml_diff>
--- a/submission/g1-incident-analyst.pptx
+++ b/submission/g1-incident-analyst.pptx
@@ -884,7 +884,7 @@
         <p:spPr>
           <a:xfrm>
             <a:off x="457200" y="320040"/>
-            <a:ext cx="5669280" cy="548640"/>
+            <a:ext cx="5943600" cy="548640"/>
           </a:xfrm>
           <a:prstGeom prst="rect">
             <a:avLst/>
@@ -900,7 +900,7 @@
               <a:buNone/>
             </a:pPr>
             <a:r>
-              <a:rPr lang="en-US" sz="3000" b="1" dirty="0">
+              <a:rPr lang="en-US" sz="2600" b="1" dirty="0">
                 <a:solidFill>
                   <a:srgbClr val="F2F5F8"/>
                 </a:solidFill>
@@ -908,9 +908,9 @@
                 <a:ea typeface="Trebuchet MS" pitchFamily="34" charset="-122"/>
                 <a:cs typeface="Trebuchet MS" pitchFamily="34" charset="-120"/>
               </a:rPr>
-              <a:t>Robot Incident Analyst</a:t>
-            </a:r>
-            <a:endParaRPr lang="en-US" sz="3000" dirty="0"/>
+              <a:t>Robotic Simulation Incident Analysis</a:t>
+            </a:r>
+            <a:endParaRPr lang="en-US" sz="2600" dirty="0"/>
           </a:p>
         </p:txBody>
       </p:sp>

</xml_diff>

<commit_message>
Lambda reviewer live: README, slide, and stage label updated
Co-Authored-By: Claude Fable 5.1 <noreply@anthropic.com>
</commit_message>
<xml_diff>
--- a/submission/g1-incident-analyst.pptx
+++ b/submission/g1-incident-analyst.pptx
@@ -1988,7 +1988,7 @@
                 <a:ea typeface="Calibri" pitchFamily="34" charset="-122"/>
                 <a:cs typeface="Calibri" pitchFamily="34" charset="-120"/>
               </a:rPr>
-              <a:t>GitHub issue through Nango: cause, evidence, before/after table, model and cost. Slack alert optional.</a:t>
+              <a:t>Reviewer on a Lambda GPU confirms the diagnosis, then Nango files the GitHub issue with evidence and the verdict.</a:t>
             </a:r>
             <a:endParaRPr lang="en-US" sz="1050" dirty="0"/>
           </a:p>
@@ -2336,7 +2336,7 @@
                 <a:ea typeface="Calibri" pitchFamily="34" charset="-122"/>
                 <a:cs typeface="Calibri" pitchFamily="34" charset="-120"/>
               </a:rPr>
-              <a:t>Fine-tune the E4B student on the Respan traces, serve it with vLLM. Next step.</a:t>
+              <a:t>Serves the reviewer model (Gemma 3 12B on a GH200) that verifies every diagnosis. Fine-tune next.</a:t>
             </a:r>
             <a:endParaRPr lang="en-US" sz="950" dirty="0"/>
           </a:p>

</xml_diff>